<commit_message>
W2 Mon: generalized moral-assistant activity + prompt-first; W3 Tue: VAP as Plan-Run-Verify with planning.md
Co-Authored-By: Claude Fable 5 <noreply@anthropic.com>
</commit_message>
<xml_diff>
--- a/slides/Week2-Mon-Values-In-Vibe-Coding.pptx
+++ b/slides/Week2-Mon-Values-In-Vibe-Coding.pptx
@@ -861,7 +861,7 @@
           <a:lstStyle/>
           <a:p>
             <a:r>
-              <a:t>From syllabus/repo 7_20. Optional precedent: Hauke's protein-suffering calculator. Reading: 'The Values Map' (Common Cause).</a:t>
+              <a:t>Generalized from the footprint framing — any moral-assistant tool qualifies (footprint calculator is one precedent, Hauke's protein-suffering calculator another). The write-prompt-first rule previews the full plan→run→verify loop on 7/28. Reading: 'The Values Map' (Common Cause).</a:t>
             </a:r>
           </a:p>
         </p:txBody>
@@ -7328,7 +7328,7 @@
                 </a:solidFill>
                 <a:latin typeface="Arial"/>
               </a:rPr>
-              <a:t>AI as Moral Assistant — Footprint Calculator</a:t>
+              <a:t>AI as Moral Assistant — build a tool that argues for a value</a:t>
             </a:r>
           </a:p>
         </p:txBody>
@@ -7376,7 +7376,7 @@
                 </a:solidFill>
                 <a:latin typeface="Arial"/>
               </a:rPr>
-              <a:t>Use AI to help yourself act more ethically.</a:t>
+              <a:t>Build a small tool that helps someone act more morally — calculator, nudge, checker, check-in.</a:t>
             </a:r>
           </a:p>
           <a:p>
@@ -7401,7 +7401,7 @@
                 </a:solidFill>
                 <a:latin typeface="Arial"/>
               </a:rPr>
-              <a:t>Vibe-code a personal calculator: feed in your last week of AI use (tokens / requests).</a:t>
+              <a:t>The tool must ARGUE for something — name the value explicitly in the UI.</a:t>
             </a:r>
           </a:p>
           <a:p>
@@ -7426,7 +7426,7 @@
                 </a:solidFill>
                 <a:latin typeface="Arial"/>
               </a:rPr>
-              <a:t>Translate it into CO₂, energy, and water — using validated data sources (cite them!).</a:t>
+              <a:t>Write your value-centered first prompt BEFORE you run it — verbatim, in your report.</a:t>
             </a:r>
           </a:p>
           <a:p>
@@ -7451,7 +7451,7 @@
                 </a:solidFill>
                 <a:latin typeface="Arial"/>
               </a:rPr>
-              <a:t>Compare it to your meals over the same week (e.g. tofu vs. beef).</a:t>
+              <a:t>Then compare: did the artifact carry YOUR value, or the tool's defaults?</a:t>
             </a:r>
           </a:p>
           <a:p>
@@ -7476,7 +7476,32 @@
                 </a:solidFill>
                 <a:latin typeface="Arial"/>
               </a:rPr>
-              <a:t>Deliverable: hosted calculator + a reflection on what changed once the numbers were visible.</a:t>
+              <a:t>Numbers need visible sources — cited on the page, not buried in the report.</a:t>
+            </a:r>
+          </a:p>
+          <a:p>
+            <a:pPr algn="l">
+              <a:lnSpc>
+                <a:spcPct val="112000"/>
+              </a:lnSpc>
+            </a:pPr>
+            <a:r>
+              <a:rPr sz="2000" b="1">
+                <a:solidFill>
+                  <a:srgbClr val="00FF41"/>
+                </a:solidFill>
+                <a:latin typeface="Arial"/>
+              </a:rPr>
+              <a:t>•  </a:t>
+            </a:r>
+            <a:r>
+              <a:rPr sz="2000" b="0">
+                <a:solidFill>
+                  <a:srgbClr val="F5F7FA"/>
+                </a:solidFill>
+                <a:latin typeface="Arial"/>
+              </a:rPr>
+              <a:t>Deliverable: hosted one-pager + reflection. Example precedents: footprint/offset calculator, protein-suffering index.</a:t>
             </a:r>
           </a:p>
         </p:txBody>

</xml_diff>

<commit_message>
W2 Mon: drop premature prompt-first rule, add no-fabrication + ambassadors slide; W3 Tue: operationalize the value
Co-Authored-By: Claude Fable 5 <noreply@anthropic.com>
</commit_message>
<xml_diff>
--- a/slides/Week2-Mon-Values-In-Vibe-Coding.pptx
+++ b/slides/Week2-Mon-Values-In-Vibe-Coding.pptx
@@ -15,6 +15,7 @@
     <p:sldId id="263" r:id="rId15"/>
     <p:sldId id="264" r:id="rId16"/>
     <p:sldId id="265" r:id="rId17"/>
+    <p:sldId id="266" r:id="rId18"/>
   </p:sldIdLst>
   <p:sldSz cx="12191695" cy="6858000" type="screen4x3"/>
   <p:notesSz cx="6858000" cy="9144000"/>
@@ -861,7 +862,77 @@
           <a:lstStyle/>
           <a:p>
             <a:r>
-              <a:t>Generalized from the footprint framing — any moral-assistant tool qualifies (footprint calculator is one precedent, Hauke's protein-suffering calculator another). The write-prompt-first rule previews the full plan→run→verify loop on 7/28. Reading: 'The Values Map' (Common Cause).</a:t>
+              <a:t>Generalized from the footprint framing — any moral-assistant tool qualifies (footprint calculator is one precedent, Hauke's protein-suffering calculator another). Hallucinated numbers/citations are the real failure mode here. Reading: 'The Values Map' (Common Cause).</a:t>
+            </a:r>
+          </a:p>
+        </p:txBody>
+      </p:sp>
+      <p:sp>
+        <p:nvSpPr>
+          <p:cNvPr id="4" name="Slide Number Placeholder 3"/>
+          <p:cNvSpPr>
+            <a:spLocks noGrp="1"/>
+          </p:cNvSpPr>
+          <p:nvPr>
+            <p:ph type="sldNum" idx="5" sz="quarter"/>
+          </p:nvPr>
+        </p:nvSpPr>
+        <p:spPr/>
+      </p:sp>
+    </p:spTree>
+  </p:cSld>
+  <p:clrMapOvr>
+    <a:masterClrMapping/>
+  </p:clrMapOvr>
+</p:notes>
+</file>
+
+<file path=ppt/notesSlides/notesSlide7.xml><?xml version="1.0" encoding="utf-8"?>
+<p:notes xmlns:a="http://schemas.openxmlformats.org/drawingml/2006/main" xmlns:p="http://schemas.openxmlformats.org/presentationml/2006/main" xmlns:r="http://schemas.openxmlformats.org/officeDocument/2006/relationships">
+  <p:cSld>
+    <p:spTree>
+      <p:nvGrpSpPr>
+        <p:cNvPr id="1" name=""/>
+        <p:cNvGrpSpPr/>
+        <p:nvPr/>
+      </p:nvGrpSpPr>
+      <p:grpSpPr>
+        <a:xfrm>
+          <a:off x="0" y="0"/>
+          <a:ext cx="0" cy="0"/>
+          <a:chOff x="0" y="0"/>
+          <a:chExt cx="0" cy="0"/>
+        </a:xfrm>
+      </p:grpSpPr>
+      <p:sp>
+        <p:nvSpPr>
+          <p:cNvPr id="2" name="Slide Image Placeholder 1"/>
+          <p:cNvSpPr>
+            <a:spLocks noGrp="1"/>
+          </p:cNvSpPr>
+          <p:nvPr>
+            <p:ph type="sldImg" idx="2"/>
+          </p:nvPr>
+        </p:nvSpPr>
+        <p:spPr/>
+      </p:sp>
+      <p:sp>
+        <p:nvSpPr>
+          <p:cNvPr id="3" name="Notes Placeholder 2"/>
+          <p:cNvSpPr>
+            <a:spLocks noGrp="1"/>
+          </p:cNvSpPr>
+          <p:nvPr>
+            <p:ph type="body" idx="3" sz="quarter"/>
+          </p:nvPr>
+        </p:nvSpPr>
+        <p:spPr/>
+        <p:txBody>
+          <a:bodyPr/>
+          <a:lstStyle/>
+          <a:p>
+            <a:r>
+              <a:t>Practical slide for project work time: how the per-team ambassador accounts work alongside Gemini Code Assist for everyone. Adjust the middle column if the role split changed.</a:t>
             </a:r>
           </a:p>
         </p:txBody>
@@ -4096,6 +4167,808 @@
                 </a:solidFill>
                 <a:latin typeface="Courier New"/>
               </a:rPr>
+              <a:t>PROJECT TIME</a:t>
+            </a:r>
+          </a:p>
+        </p:txBody>
+      </p:sp>
+      <p:sp>
+        <p:nvSpPr>
+          <p:cNvPr id="3" name="Rectangle 2"/>
+          <p:cNvSpPr/>
+          <p:nvPr/>
+        </p:nvSpPr>
+        <p:spPr>
+          <a:xfrm>
+            <a:off x="640080" y="932688"/>
+            <a:ext cx="822960" cy="73152"/>
+          </a:xfrm>
+          <a:prstGeom prst="rect">
+            <a:avLst/>
+          </a:prstGeom>
+          <a:solidFill>
+            <a:srgbClr val="00FF41"/>
+          </a:solidFill>
+          <a:ln>
+            <a:noFill/>
+          </a:ln>
+          <a:effectLst/>
+        </p:spPr>
+        <p:style>
+          <a:lnRef idx="1">
+            <a:schemeClr val="accent1"/>
+          </a:lnRef>
+          <a:fillRef idx="3">
+            <a:schemeClr val="accent1"/>
+          </a:fillRef>
+          <a:effectRef idx="2">
+            <a:schemeClr val="accent1"/>
+          </a:effectRef>
+          <a:fontRef idx="minor">
+            <a:schemeClr val="lt1"/>
+          </a:fontRef>
+        </p:style>
+        <p:txBody>
+          <a:bodyPr rtlCol="0" anchor="ctr"/>
+          <a:lstStyle/>
+          <a:p>
+            <a:pPr algn="ctr"/>
+          </a:p>
+        </p:txBody>
+      </p:sp>
+      <p:sp>
+        <p:nvSpPr>
+          <p:cNvPr id="4" name="TextBox 3"/>
+          <p:cNvSpPr txBox="1"/>
+          <p:nvPr/>
+        </p:nvSpPr>
+        <p:spPr>
+          <a:xfrm>
+            <a:off x="640080" y="1188720"/>
+            <a:ext cx="10972800" cy="914400"/>
+          </a:xfrm>
+          <a:prstGeom prst="rect">
+            <a:avLst/>
+          </a:prstGeom>
+          <a:noFill/>
+        </p:spPr>
+        <p:txBody>
+          <a:bodyPr wrap="square" anchor="t">
+            <a:spAutoFit/>
+          </a:bodyPr>
+          <a:lstStyle/>
+          <a:p>
+            <a:pPr algn="l">
+              <a:lnSpc>
+                <a:spcPct val="100000"/>
+              </a:lnSpc>
+            </a:pPr>
+            <a:r>
+              <a:rPr sz="3200" b="1">
+                <a:solidFill>
+                  <a:srgbClr val="F5F7FA"/>
+                </a:solidFill>
+                <a:latin typeface="Arial"/>
+              </a:rPr>
+              <a:t>Vibe coding ambassadors</a:t>
+            </a:r>
+          </a:p>
+        </p:txBody>
+      </p:sp>
+      <p:sp>
+        <p:nvSpPr>
+          <p:cNvPr id="5" name="Rounded Rectangle 4"/>
+          <p:cNvSpPr/>
+          <p:nvPr/>
+        </p:nvSpPr>
+        <p:spPr>
+          <a:xfrm>
+            <a:off x="640080" y="2468880"/>
+            <a:ext cx="3393338" cy="3383280"/>
+          </a:xfrm>
+          <a:prstGeom prst="roundRect">
+            <a:avLst/>
+          </a:prstGeom>
+          <a:solidFill>
+            <a:srgbClr val="151B26"/>
+          </a:solidFill>
+          <a:ln>
+            <a:noFill/>
+          </a:ln>
+          <a:effectLst/>
+        </p:spPr>
+        <p:style>
+          <a:lnRef idx="1">
+            <a:schemeClr val="accent1"/>
+          </a:lnRef>
+          <a:fillRef idx="3">
+            <a:schemeClr val="accent1"/>
+          </a:fillRef>
+          <a:effectRef idx="2">
+            <a:schemeClr val="accent1"/>
+          </a:effectRef>
+          <a:fontRef idx="minor">
+            <a:schemeClr val="lt1"/>
+          </a:fontRef>
+        </p:style>
+        <p:txBody>
+          <a:bodyPr rtlCol="0" anchor="ctr"/>
+          <a:lstStyle/>
+          <a:p>
+            <a:pPr algn="ctr"/>
+          </a:p>
+        </p:txBody>
+      </p:sp>
+      <p:sp>
+        <p:nvSpPr>
+          <p:cNvPr id="6" name="Rectangle 5"/>
+          <p:cNvSpPr/>
+          <p:nvPr/>
+        </p:nvSpPr>
+        <p:spPr>
+          <a:xfrm>
+            <a:off x="640080" y="2468880"/>
+            <a:ext cx="3393338" cy="82296"/>
+          </a:xfrm>
+          <a:prstGeom prst="rect">
+            <a:avLst/>
+          </a:prstGeom>
+          <a:solidFill>
+            <a:srgbClr val="00FF41"/>
+          </a:solidFill>
+          <a:ln>
+            <a:noFill/>
+          </a:ln>
+          <a:effectLst/>
+        </p:spPr>
+        <p:style>
+          <a:lnRef idx="1">
+            <a:schemeClr val="accent1"/>
+          </a:lnRef>
+          <a:fillRef idx="3">
+            <a:schemeClr val="accent1"/>
+          </a:fillRef>
+          <a:effectRef idx="2">
+            <a:schemeClr val="accent1"/>
+          </a:effectRef>
+          <a:fontRef idx="minor">
+            <a:schemeClr val="lt1"/>
+          </a:fontRef>
+        </p:style>
+        <p:txBody>
+          <a:bodyPr rtlCol="0" anchor="ctr"/>
+          <a:lstStyle/>
+          <a:p>
+            <a:pPr algn="ctr"/>
+          </a:p>
+        </p:txBody>
+      </p:sp>
+      <p:sp>
+        <p:nvSpPr>
+          <p:cNvPr id="7" name="TextBox 6"/>
+          <p:cNvSpPr txBox="1"/>
+          <p:nvPr/>
+        </p:nvSpPr>
+        <p:spPr>
+          <a:xfrm>
+            <a:off x="914400" y="2788920"/>
+            <a:ext cx="2844698" cy="457200"/>
+          </a:xfrm>
+          <a:prstGeom prst="rect">
+            <a:avLst/>
+          </a:prstGeom>
+          <a:noFill/>
+        </p:spPr>
+        <p:txBody>
+          <a:bodyPr wrap="square" anchor="t">
+            <a:spAutoFit/>
+          </a:bodyPr>
+          <a:lstStyle/>
+          <a:p>
+            <a:pPr algn="l">
+              <a:lnSpc>
+                <a:spcPct val="100000"/>
+              </a:lnSpc>
+            </a:pPr>
+            <a:r>
+              <a:rPr sz="1200" b="1">
+                <a:solidFill>
+                  <a:srgbClr val="00FF41"/>
+                </a:solidFill>
+                <a:latin typeface="Courier New"/>
+              </a:rPr>
+              <a:t>ONE PER TEAM</a:t>
+            </a:r>
+          </a:p>
+        </p:txBody>
+      </p:sp>
+      <p:sp>
+        <p:nvSpPr>
+          <p:cNvPr id="8" name="TextBox 7"/>
+          <p:cNvSpPr txBox="1"/>
+          <p:nvPr/>
+        </p:nvSpPr>
+        <p:spPr>
+          <a:xfrm>
+            <a:off x="914400" y="3246120"/>
+            <a:ext cx="2844698" cy="822960"/>
+          </a:xfrm>
+          <a:prstGeom prst="rect">
+            <a:avLst/>
+          </a:prstGeom>
+          <a:noFill/>
+        </p:spPr>
+        <p:txBody>
+          <a:bodyPr wrap="square" anchor="t">
+            <a:spAutoFit/>
+          </a:bodyPr>
+          <a:lstStyle/>
+          <a:p>
+            <a:pPr algn="l">
+              <a:lnSpc>
+                <a:spcPct val="100000"/>
+              </a:lnSpc>
+            </a:pPr>
+            <a:r>
+              <a:rPr sz="2000" b="1">
+                <a:solidFill>
+                  <a:srgbClr val="F5F7FA"/>
+                </a:solidFill>
+                <a:latin typeface="Arial"/>
+              </a:rPr>
+              <a:t>Your AI power user</a:t>
+            </a:r>
+          </a:p>
+        </p:txBody>
+      </p:sp>
+      <p:sp>
+        <p:nvSpPr>
+          <p:cNvPr id="9" name="TextBox 8"/>
+          <p:cNvSpPr txBox="1"/>
+          <p:nvPr/>
+        </p:nvSpPr>
+        <p:spPr>
+          <a:xfrm>
+            <a:off x="914400" y="4114800"/>
+            <a:ext cx="2844698" cy="1554480"/>
+          </a:xfrm>
+          <a:prstGeom prst="rect">
+            <a:avLst/>
+          </a:prstGeom>
+          <a:noFill/>
+        </p:spPr>
+        <p:txBody>
+          <a:bodyPr wrap="square" anchor="t">
+            <a:spAutoFit/>
+          </a:bodyPr>
+          <a:lstStyle/>
+          <a:p>
+            <a:pPr algn="l">
+              <a:lnSpc>
+                <a:spcPct val="110000"/>
+              </a:lnSpc>
+            </a:pPr>
+            <a:r>
+              <a:rPr sz="1500" b="0">
+                <a:solidFill>
+                  <a:srgbClr val="8A94A6"/>
+                </a:solidFill>
+                <a:latin typeface="Arial"/>
+              </a:rPr>
+              <a:t>Each team has an ambassador account with a stronger agentic tool. They drive the heavy builds — the rest of you still prompt on Gemini.</a:t>
+            </a:r>
+          </a:p>
+        </p:txBody>
+      </p:sp>
+      <p:sp>
+        <p:nvSpPr>
+          <p:cNvPr id="10" name="Rounded Rectangle 9"/>
+          <p:cNvSpPr/>
+          <p:nvPr/>
+        </p:nvSpPr>
+        <p:spPr>
+          <a:xfrm>
+            <a:off x="4399178" y="2468880"/>
+            <a:ext cx="3393338" cy="3383280"/>
+          </a:xfrm>
+          <a:prstGeom prst="roundRect">
+            <a:avLst/>
+          </a:prstGeom>
+          <a:solidFill>
+            <a:srgbClr val="151B26"/>
+          </a:solidFill>
+          <a:ln>
+            <a:noFill/>
+          </a:ln>
+          <a:effectLst/>
+        </p:spPr>
+        <p:style>
+          <a:lnRef idx="1">
+            <a:schemeClr val="accent1"/>
+          </a:lnRef>
+          <a:fillRef idx="3">
+            <a:schemeClr val="accent1"/>
+          </a:fillRef>
+          <a:effectRef idx="2">
+            <a:schemeClr val="accent1"/>
+          </a:effectRef>
+          <a:fontRef idx="minor">
+            <a:schemeClr val="lt1"/>
+          </a:fontRef>
+        </p:style>
+        <p:txBody>
+          <a:bodyPr rtlCol="0" anchor="ctr"/>
+          <a:lstStyle/>
+          <a:p>
+            <a:pPr algn="ctr"/>
+          </a:p>
+        </p:txBody>
+      </p:sp>
+      <p:sp>
+        <p:nvSpPr>
+          <p:cNvPr id="11" name="Rectangle 10"/>
+          <p:cNvSpPr/>
+          <p:nvPr/>
+        </p:nvSpPr>
+        <p:spPr>
+          <a:xfrm>
+            <a:off x="4399178" y="2468880"/>
+            <a:ext cx="3393338" cy="82296"/>
+          </a:xfrm>
+          <a:prstGeom prst="rect">
+            <a:avLst/>
+          </a:prstGeom>
+          <a:solidFill>
+            <a:srgbClr val="00FF41"/>
+          </a:solidFill>
+          <a:ln>
+            <a:noFill/>
+          </a:ln>
+          <a:effectLst/>
+        </p:spPr>
+        <p:style>
+          <a:lnRef idx="1">
+            <a:schemeClr val="accent1"/>
+          </a:lnRef>
+          <a:fillRef idx="3">
+            <a:schemeClr val="accent1"/>
+          </a:fillRef>
+          <a:effectRef idx="2">
+            <a:schemeClr val="accent1"/>
+          </a:effectRef>
+          <a:fontRef idx="minor">
+            <a:schemeClr val="lt1"/>
+          </a:fontRef>
+        </p:style>
+        <p:txBody>
+          <a:bodyPr rtlCol="0" anchor="ctr"/>
+          <a:lstStyle/>
+          <a:p>
+            <a:pPr algn="ctr"/>
+          </a:p>
+        </p:txBody>
+      </p:sp>
+      <p:sp>
+        <p:nvSpPr>
+          <p:cNvPr id="12" name="TextBox 11"/>
+          <p:cNvSpPr txBox="1"/>
+          <p:nvPr/>
+        </p:nvSpPr>
+        <p:spPr>
+          <a:xfrm>
+            <a:off x="4673498" y="2788920"/>
+            <a:ext cx="2844698" cy="457200"/>
+          </a:xfrm>
+          <a:prstGeom prst="rect">
+            <a:avLst/>
+          </a:prstGeom>
+          <a:noFill/>
+        </p:spPr>
+        <p:txBody>
+          <a:bodyPr wrap="square" anchor="t">
+            <a:spAutoFit/>
+          </a:bodyPr>
+          <a:lstStyle/>
+          <a:p>
+            <a:pPr algn="l">
+              <a:lnSpc>
+                <a:spcPct val="100000"/>
+              </a:lnSpc>
+            </a:pPr>
+            <a:r>
+              <a:rPr sz="1200" b="1">
+                <a:solidFill>
+                  <a:srgbClr val="00FF41"/>
+                </a:solidFill>
+                <a:latin typeface="Courier New"/>
+              </a:rPr>
+              <a:t>ROTATE THE DRIVER</a:t>
+            </a:r>
+          </a:p>
+        </p:txBody>
+      </p:sp>
+      <p:sp>
+        <p:nvSpPr>
+          <p:cNvPr id="13" name="TextBox 12"/>
+          <p:cNvSpPr txBox="1"/>
+          <p:nvPr/>
+        </p:nvSpPr>
+        <p:spPr>
+          <a:xfrm>
+            <a:off x="4673498" y="3246120"/>
+            <a:ext cx="2844698" cy="822960"/>
+          </a:xfrm>
+          <a:prstGeom prst="rect">
+            <a:avLst/>
+          </a:prstGeom>
+          <a:noFill/>
+        </p:spPr>
+        <p:txBody>
+          <a:bodyPr wrap="square" anchor="t">
+            <a:spAutoFit/>
+          </a:bodyPr>
+          <a:lstStyle/>
+          <a:p>
+            <a:pPr algn="l">
+              <a:lnSpc>
+                <a:spcPct val="100000"/>
+              </a:lnSpc>
+            </a:pPr>
+            <a:r>
+              <a:rPr sz="2000" b="1">
+                <a:solidFill>
+                  <a:srgbClr val="F5F7FA"/>
+                </a:solidFill>
+                <a:latin typeface="Arial"/>
+              </a:rPr>
+              <a:t>Not a bottleneck</a:t>
+            </a:r>
+          </a:p>
+        </p:txBody>
+      </p:sp>
+      <p:sp>
+        <p:nvSpPr>
+          <p:cNvPr id="14" name="TextBox 13"/>
+          <p:cNvSpPr txBox="1"/>
+          <p:nvPr/>
+        </p:nvSpPr>
+        <p:spPr>
+          <a:xfrm>
+            <a:off x="4673498" y="4114800"/>
+            <a:ext cx="2844698" cy="1554480"/>
+          </a:xfrm>
+          <a:prstGeom prst="rect">
+            <a:avLst/>
+          </a:prstGeom>
+          <a:noFill/>
+        </p:spPr>
+        <p:txBody>
+          <a:bodyPr wrap="square" anchor="t">
+            <a:spAutoFit/>
+          </a:bodyPr>
+          <a:lstStyle/>
+          <a:p>
+            <a:pPr algn="l">
+              <a:lnSpc>
+                <a:spcPct val="110000"/>
+              </a:lnSpc>
+            </a:pPr>
+            <a:r>
+              <a:rPr sz="1500" b="0">
+                <a:solidFill>
+                  <a:srgbClr val="8A94A6"/>
+                </a:solidFill>
+                <a:latin typeface="Arial"/>
+              </a:rPr>
+              <a:t>The ambassador runs the session, but everyone takes the keyboard. Every member's prompts must show up in history.md.</a:t>
+            </a:r>
+          </a:p>
+        </p:txBody>
+      </p:sp>
+      <p:sp>
+        <p:nvSpPr>
+          <p:cNvPr id="15" name="Rounded Rectangle 14"/>
+          <p:cNvSpPr/>
+          <p:nvPr/>
+        </p:nvSpPr>
+        <p:spPr>
+          <a:xfrm>
+            <a:off x="8158276" y="2468880"/>
+            <a:ext cx="3393338" cy="3383280"/>
+          </a:xfrm>
+          <a:prstGeom prst="roundRect">
+            <a:avLst/>
+          </a:prstGeom>
+          <a:solidFill>
+            <a:srgbClr val="151B26"/>
+          </a:solidFill>
+          <a:ln>
+            <a:noFill/>
+          </a:ln>
+          <a:effectLst/>
+        </p:spPr>
+        <p:style>
+          <a:lnRef idx="1">
+            <a:schemeClr val="accent1"/>
+          </a:lnRef>
+          <a:fillRef idx="3">
+            <a:schemeClr val="accent1"/>
+          </a:fillRef>
+          <a:effectRef idx="2">
+            <a:schemeClr val="accent1"/>
+          </a:effectRef>
+          <a:fontRef idx="minor">
+            <a:schemeClr val="lt1"/>
+          </a:fontRef>
+        </p:style>
+        <p:txBody>
+          <a:bodyPr rtlCol="0" anchor="ctr"/>
+          <a:lstStyle/>
+          <a:p>
+            <a:pPr algn="ctr"/>
+          </a:p>
+        </p:txBody>
+      </p:sp>
+      <p:sp>
+        <p:nvSpPr>
+          <p:cNvPr id="16" name="Rectangle 15"/>
+          <p:cNvSpPr/>
+          <p:nvPr/>
+        </p:nvSpPr>
+        <p:spPr>
+          <a:xfrm>
+            <a:off x="8158276" y="2468880"/>
+            <a:ext cx="3393338" cy="82296"/>
+          </a:xfrm>
+          <a:prstGeom prst="rect">
+            <a:avLst/>
+          </a:prstGeom>
+          <a:solidFill>
+            <a:srgbClr val="00FF41"/>
+          </a:solidFill>
+          <a:ln>
+            <a:noFill/>
+          </a:ln>
+          <a:effectLst/>
+        </p:spPr>
+        <p:style>
+          <a:lnRef idx="1">
+            <a:schemeClr val="accent1"/>
+          </a:lnRef>
+          <a:fillRef idx="3">
+            <a:schemeClr val="accent1"/>
+          </a:fillRef>
+          <a:effectRef idx="2">
+            <a:schemeClr val="accent1"/>
+          </a:effectRef>
+          <a:fontRef idx="minor">
+            <a:schemeClr val="lt1"/>
+          </a:fontRef>
+        </p:style>
+        <p:txBody>
+          <a:bodyPr rtlCol="0" anchor="ctr"/>
+          <a:lstStyle/>
+          <a:p>
+            <a:pPr algn="ctr"/>
+          </a:p>
+        </p:txBody>
+      </p:sp>
+      <p:sp>
+        <p:nvSpPr>
+          <p:cNvPr id="17" name="TextBox 16"/>
+          <p:cNvSpPr txBox="1"/>
+          <p:nvPr/>
+        </p:nvSpPr>
+        <p:spPr>
+          <a:xfrm>
+            <a:off x="8432596" y="2788920"/>
+            <a:ext cx="2844698" cy="457200"/>
+          </a:xfrm>
+          <a:prstGeom prst="rect">
+            <a:avLst/>
+          </a:prstGeom>
+          <a:noFill/>
+        </p:spPr>
+        <p:txBody>
+          <a:bodyPr wrap="square" anchor="t">
+            <a:spAutoFit/>
+          </a:bodyPr>
+          <a:lstStyle/>
+          <a:p>
+            <a:pPr algn="l">
+              <a:lnSpc>
+                <a:spcPct val="100000"/>
+              </a:lnSpc>
+            </a:pPr>
+            <a:r>
+              <a:rPr sz="1200" b="1">
+                <a:solidFill>
+                  <a:srgbClr val="00FF41"/>
+                </a:solidFill>
+                <a:latin typeface="Courier New"/>
+              </a:rPr>
+              <a:t>ASK EARLY</a:t>
+            </a:r>
+          </a:p>
+        </p:txBody>
+      </p:sp>
+      <p:sp>
+        <p:nvSpPr>
+          <p:cNvPr id="18" name="TextBox 17"/>
+          <p:cNvSpPr txBox="1"/>
+          <p:nvPr/>
+        </p:nvSpPr>
+        <p:spPr>
+          <a:xfrm>
+            <a:off x="8432596" y="3246120"/>
+            <a:ext cx="2844698" cy="822960"/>
+          </a:xfrm>
+          <a:prstGeom prst="rect">
+            <a:avLst/>
+          </a:prstGeom>
+          <a:noFill/>
+        </p:spPr>
+        <p:txBody>
+          <a:bodyPr wrap="square" anchor="t">
+            <a:spAutoFit/>
+          </a:bodyPr>
+          <a:lstStyle/>
+          <a:p>
+            <a:pPr algn="l">
+              <a:lnSpc>
+                <a:spcPct val="100000"/>
+              </a:lnSpc>
+            </a:pPr>
+            <a:r>
+              <a:rPr sz="2000" b="1">
+                <a:solidFill>
+                  <a:srgbClr val="F5F7FA"/>
+                </a:solidFill>
+                <a:latin typeface="Arial"/>
+              </a:rPr>
+              <a:t>Don't burn the day</a:t>
+            </a:r>
+          </a:p>
+        </p:txBody>
+      </p:sp>
+      <p:sp>
+        <p:nvSpPr>
+          <p:cNvPr id="19" name="TextBox 18"/>
+          <p:cNvSpPr txBox="1"/>
+          <p:nvPr/>
+        </p:nvSpPr>
+        <p:spPr>
+          <a:xfrm>
+            <a:off x="8432596" y="4114800"/>
+            <a:ext cx="2844698" cy="1554480"/>
+          </a:xfrm>
+          <a:prstGeom prst="rect">
+            <a:avLst/>
+          </a:prstGeom>
+          <a:noFill/>
+        </p:spPr>
+        <p:txBody>
+          <a:bodyPr wrap="square" anchor="t">
+            <a:spAutoFit/>
+          </a:bodyPr>
+          <a:lstStyle/>
+          <a:p>
+            <a:pPr algn="l">
+              <a:lnSpc>
+                <a:spcPct val="110000"/>
+              </a:lnSpc>
+            </a:pPr>
+            <a:r>
+              <a:rPr sz="1500" b="0">
+                <a:solidFill>
+                  <a:srgbClr val="8A94A6"/>
+                </a:solidFill>
+                <a:latin typeface="Arial"/>
+              </a:rPr>
+              <a:t>Blocked on access, quota, or setup? Flag it at the start of project time — not at 11:55.</a:t>
+            </a:r>
+          </a:p>
+        </p:txBody>
+      </p:sp>
+      <p:sp>
+        <p:nvSpPr>
+          <p:cNvPr id="20" name="TextBox 19"/>
+          <p:cNvSpPr txBox="1"/>
+          <p:nvPr/>
+        </p:nvSpPr>
+        <p:spPr>
+          <a:xfrm>
+            <a:off x="640080" y="6355080"/>
+            <a:ext cx="10972800" cy="365760"/>
+          </a:xfrm>
+          <a:prstGeom prst="rect">
+            <a:avLst/>
+          </a:prstGeom>
+          <a:noFill/>
+        </p:spPr>
+        <p:txBody>
+          <a:bodyPr wrap="square" anchor="t">
+            <a:spAutoFit/>
+          </a:bodyPr>
+          <a:lstStyle/>
+          <a:p>
+            <a:pPr algn="l">
+              <a:lnSpc>
+                <a:spcPct val="100000"/>
+              </a:lnSpc>
+            </a:pPr>
+            <a:r>
+              <a:rPr sz="1000" b="0">
+                <a:solidFill>
+                  <a:srgbClr val="5A6474"/>
+                </a:solidFill>
+                <a:latin typeface="Courier New"/>
+              </a:rPr>
+              <a:t>Good Code, Good Vibes · TECHIE 1121 · Cornell Tech · Summer 2026</a:t>
+            </a:r>
+          </a:p>
+        </p:txBody>
+      </p:sp>
+    </p:spTree>
+  </p:cSld>
+  <p:clrMapOvr>
+    <a:masterClrMapping/>
+  </p:clrMapOvr>
+</p:sld>
+</file>
+
+<file path=ppt/slides/slide11.xml><?xml version="1.0" encoding="utf-8"?>
+<p:sld xmlns:a="http://schemas.openxmlformats.org/drawingml/2006/main" xmlns:p="http://schemas.openxmlformats.org/presentationml/2006/main" xmlns:r="http://schemas.openxmlformats.org/officeDocument/2006/relationships">
+  <p:cSld>
+    <p:bg>
+      <p:bgPr>
+        <a:solidFill>
+          <a:srgbClr val="0B0E14"/>
+        </a:solidFill>
+        <a:effectLst/>
+      </p:bgPr>
+    </p:bg>
+    <p:spTree>
+      <p:nvGrpSpPr>
+        <p:cNvPr id="1" name=""/>
+        <p:cNvGrpSpPr/>
+        <p:nvPr/>
+      </p:nvGrpSpPr>
+      <p:grpSpPr/>
+      <p:sp>
+        <p:nvSpPr>
+          <p:cNvPr id="2" name="TextBox 1"/>
+          <p:cNvSpPr txBox="1"/>
+          <p:nvPr/>
+        </p:nvSpPr>
+        <p:spPr>
+          <a:xfrm>
+            <a:off x="640080" y="502920"/>
+            <a:ext cx="10058400" cy="365760"/>
+          </a:xfrm>
+          <a:prstGeom prst="rect">
+            <a:avLst/>
+          </a:prstGeom>
+          <a:noFill/>
+        </p:spPr>
+        <p:txBody>
+          <a:bodyPr wrap="square" anchor="t">
+            <a:spAutoFit/>
+          </a:bodyPr>
+          <a:lstStyle/>
+          <a:p>
+            <a:pPr algn="l">
+              <a:lnSpc>
+                <a:spcPct val="100000"/>
+              </a:lnSpc>
+            </a:pPr>
+            <a:r>
+              <a:rPr sz="1300" b="1">
+                <a:solidFill>
+                  <a:srgbClr val="00FF41"/>
+                </a:solidFill>
+                <a:latin typeface="Courier New"/>
+              </a:rPr>
               <a:t>WHAT’S NEXT</a:t>
             </a:r>
           </a:p>
@@ -7426,7 +8299,7 @@
                 </a:solidFill>
                 <a:latin typeface="Arial"/>
               </a:rPr>
-              <a:t>Write your value-centered first prompt BEFORE you run it — verbatim, in your report.</a:t>
+              <a:t>Keep it small: one page, built and hosted in one session.</a:t>
             </a:r>
           </a:p>
           <a:p>
@@ -7451,32 +8324,7 @@
                 </a:solidFill>
                 <a:latin typeface="Arial"/>
               </a:rPr>
-              <a:t>Then compare: did the artifact carry YOUR value, or the tool's defaults?</a:t>
-            </a:r>
-          </a:p>
-          <a:p>
-            <a:pPr algn="l">
-              <a:lnSpc>
-                <a:spcPct val="112000"/>
-              </a:lnSpc>
-            </a:pPr>
-            <a:r>
-              <a:rPr sz="2000" b="1">
-                <a:solidFill>
-                  <a:srgbClr val="00FF41"/>
-                </a:solidFill>
-                <a:latin typeface="Arial"/>
-              </a:rPr>
-              <a:t>•  </a:t>
-            </a:r>
-            <a:r>
-              <a:rPr sz="2000" b="0">
-                <a:solidFill>
-                  <a:srgbClr val="F5F7FA"/>
-                </a:solidFill>
-                <a:latin typeface="Arial"/>
-              </a:rPr>
-              <a:t>Numbers need visible sources — cited on the page, not buried in the report.</a:t>
+              <a:t>Don't let it fabricate the facts people decide on — check the AI's sources, or say you're estimating.</a:t>
             </a:r>
           </a:p>
           <a:p>

</xml_diff>